<commit_message>
fix: guard against missing vix_yield_curve_signal_history.csv
- Made pd.read_csv conditional (file may not exist if pipeline hasn't generated it)
- Added empty DataFrame guard in _save_signal_history_figure for missing vix_z column
- Pipeline now completes successfully: 8.39% return, 7.25% vol, -21.9% MDD
- 68 tests pass
</commit_message>
<xml_diff>
--- a/taa_project/outputs/reports/whitmore_deck.pptx
+++ b/taa_project/outputs/reports/whitmore_deck.pptx
@@ -4586,7 +4586,7 @@
               </a:defRPr>
             </a:pPr>
             <a:r>
-              <a:t>Deflated Sharpe Ratio: 0.941 across 701 disclosed trials (Bailey &amp; Lopez de Prado, 2014).</a:t>
+              <a:t>Deflated Sharpe Ratio: 0.939 across 738 disclosed trials (Bailey &amp; Lopez de Prado, 2014).</a:t>
             </a:r>
           </a:p>
         </p:txBody>
@@ -5742,7 +5742,7 @@
               </a:defRPr>
             </a:pPr>
             <a:r>
-              <a:t>  12 hard (emergency portfolio edge case)</a:t>
+              <a:t>  0 hard (emergency portfolio edge case)</a:t>
             </a:r>
           </a:p>
           <a:p>
@@ -7187,7 +7187,7 @@
               </a:defRPr>
             </a:pPr>
             <a:r>
-              <a:t>68 unit tests  |  701 disclosed trials  |  5 walk-forward folds  |  DSR 0.941</a:t>
+              <a:t>68 unit tests  |  738 disclosed trials  |  5 walk-forward folds  |  DSR 0.939</a:t>
             </a:r>
           </a:p>
         </p:txBody>
@@ -8685,7 +8685,7 @@
                         </a:defRPr>
                       </a:pPr>
                       <a:r>
-                        <a:t>7.91%</a:t>
+                        <a:t>7.88%</a:t>
                       </a:r>
                     </a:p>
                   </a:txBody>
@@ -8709,7 +8709,7 @@
                         </a:defRPr>
                       </a:pPr>
                       <a:r>
-                        <a:t>8.62%</a:t>
+                        <a:t>8.64%</a:t>
                       </a:r>
                     </a:p>
                   </a:txBody>
@@ -8757,7 +8757,7 @@
                         </a:defRPr>
                       </a:pPr>
                       <a:r>
-                        <a:t>0.69</a:t>
+                        <a:t>0.68</a:t>
                       </a:r>
                     </a:p>
                   </a:txBody>
@@ -8831,7 +8831,7 @@
                         </a:defRPr>
                       </a:pPr>
                       <a:r>
-                        <a:t>9.25%</a:t>
+                        <a:t>9.26%</a:t>
                       </a:r>
                     </a:p>
                   </a:txBody>
@@ -8929,7 +8929,7 @@
                         </a:defRPr>
                       </a:pPr>
                       <a:r>
-                        <a:t>6.91%</a:t>
+                        <a:t>6.88%</a:t>
                       </a:r>
                     </a:p>
                   </a:txBody>
@@ -8953,7 +8953,7 @@
                         </a:defRPr>
                       </a:pPr>
                       <a:r>
-                        <a:t>8.21%</a:t>
+                        <a:t>8.20%</a:t>
                       </a:r>
                     </a:p>
                   </a:txBody>
@@ -9001,7 +9001,7 @@
                         </a:defRPr>
                       </a:pPr>
                       <a:r>
-                        <a:t>0.60</a:t>
+                        <a:t>0.59</a:t>
                       </a:r>
                     </a:p>
                   </a:txBody>
@@ -9051,7 +9051,7 @@
                         </a:defRPr>
                       </a:pPr>
                       <a:r>
-                        <a:t>8.01%</a:t>
+                        <a:t>8.05%</a:t>
                       </a:r>
                     </a:p>
                   </a:txBody>
@@ -9075,7 +9075,7 @@
                         </a:defRPr>
                       </a:pPr>
                       <a:r>
-                        <a:t>10.22%</a:t>
+                        <a:t>10.31%</a:t>
                       </a:r>
                     </a:p>
                   </a:txBody>
@@ -9173,7 +9173,7 @@
                         </a:defRPr>
                       </a:pPr>
                       <a:r>
-                        <a:t>6.55%</a:t>
+                        <a:t>6.53%</a:t>
                       </a:r>
                     </a:p>
                   </a:txBody>
@@ -9197,7 +9197,7 @@
                         </a:defRPr>
                       </a:pPr>
                       <a:r>
-                        <a:t>7.74%</a:t>
+                        <a:t>7.72%</a:t>
                       </a:r>
                     </a:p>
                   </a:txBody>
@@ -11102,7 +11102,7 @@
               </a:defRPr>
             </a:pPr>
             <a:r>
-              <a:t>DSR: 0.941</a:t>
+              <a:t>DSR: 0.939</a:t>
             </a:r>
           </a:p>
           <a:p>
@@ -11118,7 +11118,7 @@
               </a:defRPr>
             </a:pPr>
             <a:r>
-              <a:t>Across 701 disclosed trials</a:t>
+              <a:t>Across 738 disclosed trials</a:t>
             </a:r>
           </a:p>
         </p:txBody>

</xml_diff>